<commit_message>
data-eng 5-3 덱 5(w5d3s0 신설) · 4-5·5-1·5-2 덱 「5-3 에서 다시 씀」 고침 · 묶음
</commit_message>
<xml_diff>
--- a/data-eng/decks/w5d1s0.pptx
+++ b/data-eng/decks/w5d1s0.pptx
@@ -5371,7 +5371,7 @@
                 <a:ea typeface="Pretendard"/>
                 <a:cs typeface="Pretendard"/>
               </a:rPr>
-              <a:t>4주차 테이블은 지우지 않는다 — 5-3 에서 다시 쓴다</a:t>
+              <a:t>4주차 테이블은 지우지 않는다 — 4주차 결과물</a:t>
             </a:r>
           </a:p>
         </p:txBody>
@@ -7271,7 +7271,7 @@
                 <a:ea typeface="Pretendard"/>
                 <a:cs typeface="Pretendard"/>
               </a:rPr>
-              <a:t>down -v 는 4주차 테이블을 지운다 — 5-3 에서 다시 쓴다</a:t>
+              <a:t>down -v 는 4주차 테이블을 지운다 — 4주차 결과물</a:t>
             </a:r>
           </a:p>
         </p:txBody>

</xml_diff>